<commit_message>
Fix the typo error in the code and document.
</commit_message>
<xml_diff>
--- a/doc/designDoc.pptx
+++ b/doc/designDoc.pptx
@@ -6,8 +6,7 @@
   </p:sldMasterIdLst>
   <p:sldIdLst>
     <p:sldId id="256" r:id="rId2"/>
-    <p:sldId id="302" r:id="rId3"/>
-    <p:sldId id="303" r:id="rId4"/>
+    <p:sldId id="303" r:id="rId3"/>
   </p:sldIdLst>
   <p:sldSz cx="12192000" cy="6858000"/>
   <p:notesSz cx="6858000" cy="9144000"/>
@@ -106,6 +105,11 @@
       </a:defRPr>
     </a:lvl9pPr>
   </p:defaultTextStyle>
+  <p:extLst>
+    <p:ext uri="{EFAFB233-063F-42B5-8137-9DF3F51BA10A}">
+      <p15:sldGuideLst xmlns:p15="http://schemas.microsoft.com/office/powerpoint/2012/main"/>
+    </p:ext>
+  </p:extLst>
 </p:presentation>
 </file>
 
@@ -258,7 +262,7 @@
           <a:p>
             <a:fld id="{F7859B24-8C9A-4065-B398-5B8315357CEA}" type="datetimeFigureOut">
               <a:rPr lang="en-SG" smtClean="0"/>
-              <a:t>25/9/2024</a:t>
+              <a:t>17/4/2025</a:t>
             </a:fld>
             <a:endParaRPr lang="en-SG"/>
           </a:p>
@@ -458,7 +462,7 @@
           <a:p>
             <a:fld id="{F7859B24-8C9A-4065-B398-5B8315357CEA}" type="datetimeFigureOut">
               <a:rPr lang="en-SG" smtClean="0"/>
-              <a:t>25/9/2024</a:t>
+              <a:t>17/4/2025</a:t>
             </a:fld>
             <a:endParaRPr lang="en-SG"/>
           </a:p>
@@ -668,7 +672,7 @@
           <a:p>
             <a:fld id="{F7859B24-8C9A-4065-B398-5B8315357CEA}" type="datetimeFigureOut">
               <a:rPr lang="en-SG" smtClean="0"/>
-              <a:t>25/9/2024</a:t>
+              <a:t>17/4/2025</a:t>
             </a:fld>
             <a:endParaRPr lang="en-SG"/>
           </a:p>
@@ -868,7 +872,7 @@
           <a:p>
             <a:fld id="{F7859B24-8C9A-4065-B398-5B8315357CEA}" type="datetimeFigureOut">
               <a:rPr lang="en-SG" smtClean="0"/>
-              <a:t>25/9/2024</a:t>
+              <a:t>17/4/2025</a:t>
             </a:fld>
             <a:endParaRPr lang="en-SG"/>
           </a:p>
@@ -1144,7 +1148,7 @@
           <a:p>
             <a:fld id="{F7859B24-8C9A-4065-B398-5B8315357CEA}" type="datetimeFigureOut">
               <a:rPr lang="en-SG" smtClean="0"/>
-              <a:t>25/9/2024</a:t>
+              <a:t>17/4/2025</a:t>
             </a:fld>
             <a:endParaRPr lang="en-SG"/>
           </a:p>
@@ -1412,7 +1416,7 @@
           <a:p>
             <a:fld id="{F7859B24-8C9A-4065-B398-5B8315357CEA}" type="datetimeFigureOut">
               <a:rPr lang="en-SG" smtClean="0"/>
-              <a:t>25/9/2024</a:t>
+              <a:t>17/4/2025</a:t>
             </a:fld>
             <a:endParaRPr lang="en-SG"/>
           </a:p>
@@ -1827,7 +1831,7 @@
           <a:p>
             <a:fld id="{F7859B24-8C9A-4065-B398-5B8315357CEA}" type="datetimeFigureOut">
               <a:rPr lang="en-SG" smtClean="0"/>
-              <a:t>25/9/2024</a:t>
+              <a:t>17/4/2025</a:t>
             </a:fld>
             <a:endParaRPr lang="en-SG"/>
           </a:p>
@@ -1969,7 +1973,7 @@
           <a:p>
             <a:fld id="{F7859B24-8C9A-4065-B398-5B8315357CEA}" type="datetimeFigureOut">
               <a:rPr lang="en-SG" smtClean="0"/>
-              <a:t>25/9/2024</a:t>
+              <a:t>17/4/2025</a:t>
             </a:fld>
             <a:endParaRPr lang="en-SG"/>
           </a:p>
@@ -2082,7 +2086,7 @@
           <a:p>
             <a:fld id="{F7859B24-8C9A-4065-B398-5B8315357CEA}" type="datetimeFigureOut">
               <a:rPr lang="en-SG" smtClean="0"/>
-              <a:t>25/9/2024</a:t>
+              <a:t>17/4/2025</a:t>
             </a:fld>
             <a:endParaRPr lang="en-SG"/>
           </a:p>
@@ -2395,7 +2399,7 @@
           <a:p>
             <a:fld id="{F7859B24-8C9A-4065-B398-5B8315357CEA}" type="datetimeFigureOut">
               <a:rPr lang="en-SG" smtClean="0"/>
-              <a:t>25/9/2024</a:t>
+              <a:t>17/4/2025</a:t>
             </a:fld>
             <a:endParaRPr lang="en-SG"/>
           </a:p>
@@ -2684,7 +2688,7 @@
           <a:p>
             <a:fld id="{F7859B24-8C9A-4065-B398-5B8315357CEA}" type="datetimeFigureOut">
               <a:rPr lang="en-SG" smtClean="0"/>
-              <a:t>25/9/2024</a:t>
+              <a:t>17/4/2025</a:t>
             </a:fld>
             <a:endParaRPr lang="en-SG"/>
           </a:p>
@@ -2927,7 +2931,7 @@
           <a:p>
             <a:fld id="{F7859B24-8C9A-4065-B398-5B8315357CEA}" type="datetimeFigureOut">
               <a:rPr lang="en-SG" smtClean="0"/>
-              <a:t>25/9/2024</a:t>
+              <a:t>17/4/2025</a:t>
             </a:fld>
             <a:endParaRPr lang="en-SG"/>
           </a:p>
@@ -3366,7 +3370,7 @@
         </p:blipFill>
         <p:spPr>
           <a:xfrm>
-            <a:off x="3276845" y="2548283"/>
+            <a:off x="3185405" y="1441859"/>
             <a:ext cx="1190634" cy="1091414"/>
           </a:xfrm>
           <a:prstGeom prst="rect">
@@ -3402,7 +3406,7 @@
         </p:blipFill>
         <p:spPr>
           <a:xfrm>
-            <a:off x="4062205" y="3105912"/>
+            <a:off x="3970765" y="1999488"/>
             <a:ext cx="501153" cy="420968"/>
           </a:xfrm>
           <a:prstGeom prst="rect">
@@ -3443,7 +3447,7 @@
         </p:blipFill>
         <p:spPr>
           <a:xfrm flipH="1">
-            <a:off x="5208561" y="2964922"/>
+            <a:off x="5117121" y="1858498"/>
             <a:ext cx="666005" cy="559444"/>
           </a:xfrm>
           <a:prstGeom prst="rect">
@@ -3470,7 +3474,7 @@
         </p:nvSpPr>
         <p:spPr>
           <a:xfrm rot="989087" flipH="1">
-            <a:off x="4152617" y="2245350"/>
+            <a:off x="4061177" y="1138926"/>
             <a:ext cx="1323229" cy="472046"/>
           </a:xfrm>
           <a:prstGeom prst="curvedDownArrow">
@@ -3523,7 +3527,7 @@
         </p:nvSpPr>
         <p:spPr>
           <a:xfrm rot="10800000" flipH="1">
-            <a:off x="4546638" y="3624049"/>
+            <a:off x="4455198" y="2517625"/>
             <a:ext cx="761272" cy="236393"/>
           </a:xfrm>
           <a:prstGeom prst="curvedDownArrow">
@@ -3581,7 +3585,7 @@
         </p:nvCxnSpPr>
         <p:spPr>
           <a:xfrm flipV="1">
-            <a:off x="4467479" y="2964922"/>
+            <a:off x="4376039" y="1858498"/>
             <a:ext cx="741082" cy="252280"/>
           </a:xfrm>
           <a:prstGeom prst="straightConnector1">
@@ -3623,7 +3627,7 @@
         </p:nvCxnSpPr>
         <p:spPr>
           <a:xfrm>
-            <a:off x="4467479" y="3214883"/>
+            <a:off x="4376039" y="2108459"/>
             <a:ext cx="741082" cy="270193"/>
           </a:xfrm>
           <a:prstGeom prst="straightConnector1">
@@ -3665,7 +3669,7 @@
         </p:nvCxnSpPr>
         <p:spPr>
           <a:xfrm flipH="1" flipV="1">
-            <a:off x="4467479" y="2588271"/>
+            <a:off x="4376039" y="1481847"/>
             <a:ext cx="877450" cy="559444"/>
           </a:xfrm>
           <a:prstGeom prst="straightConnector1">
@@ -3710,7 +3714,7 @@
         </p:nvCxnSpPr>
         <p:spPr>
           <a:xfrm flipH="1">
-            <a:off x="4626869" y="3155539"/>
+            <a:off x="4535429" y="2049115"/>
             <a:ext cx="746544" cy="329537"/>
           </a:xfrm>
           <a:prstGeom prst="straightConnector1">
@@ -3769,7 +3773,7 @@
         </p:blipFill>
         <p:spPr>
           <a:xfrm>
-            <a:off x="6943358" y="2338920"/>
+            <a:off x="6851918" y="1232496"/>
             <a:ext cx="610303" cy="559444"/>
           </a:xfrm>
           <a:prstGeom prst="rect">
@@ -3805,7 +3809,7 @@
         </p:blipFill>
         <p:spPr>
           <a:xfrm>
-            <a:off x="7248888" y="2655916"/>
+            <a:off x="7157448" y="1549492"/>
             <a:ext cx="358182" cy="300872"/>
           </a:xfrm>
           <a:prstGeom prst="rect">
@@ -3848,7 +3852,7 @@
         </p:blipFill>
         <p:spPr>
           <a:xfrm>
-            <a:off x="9325497" y="2338920"/>
+            <a:off x="9234057" y="1232496"/>
             <a:ext cx="610303" cy="559444"/>
           </a:xfrm>
           <a:prstGeom prst="rect">
@@ -3884,7 +3888,7 @@
         </p:blipFill>
         <p:spPr>
           <a:xfrm>
-            <a:off x="9263890" y="2687608"/>
+            <a:off x="9172450" y="1581184"/>
             <a:ext cx="358182" cy="300872"/>
           </a:xfrm>
           <a:prstGeom prst="rect">
@@ -3927,7 +3931,7 @@
         </p:blipFill>
         <p:spPr>
           <a:xfrm>
-            <a:off x="7965631" y="3540284"/>
+            <a:off x="7874191" y="2433860"/>
             <a:ext cx="610303" cy="559444"/>
           </a:xfrm>
           <a:prstGeom prst="rect">
@@ -3963,7 +3967,7 @@
         </p:blipFill>
         <p:spPr>
           <a:xfrm>
-            <a:off x="8270782" y="3429138"/>
+            <a:off x="8179342" y="2322714"/>
             <a:ext cx="358182" cy="300872"/>
           </a:xfrm>
           <a:prstGeom prst="rect">
@@ -3993,7 +3997,7 @@
         </p:nvCxnSpPr>
         <p:spPr>
           <a:xfrm>
-            <a:off x="7607070" y="2806352"/>
+            <a:off x="7515630" y="1699928"/>
             <a:ext cx="356970" cy="773222"/>
           </a:xfrm>
           <a:prstGeom prst="straightConnector1">
@@ -4035,7 +4039,7 @@
         </p:nvCxnSpPr>
         <p:spPr>
           <a:xfrm flipV="1">
-            <a:off x="7615268" y="2402284"/>
+            <a:off x="7523828" y="1295860"/>
             <a:ext cx="1776865" cy="285324"/>
           </a:xfrm>
           <a:prstGeom prst="straightConnector1">
@@ -4077,7 +4081,7 @@
         </p:nvCxnSpPr>
         <p:spPr>
           <a:xfrm flipH="1" flipV="1">
-            <a:off x="7553661" y="2402284"/>
+            <a:off x="7462221" y="1295860"/>
             <a:ext cx="1075303" cy="1026854"/>
           </a:xfrm>
           <a:prstGeom prst="straightConnector1">
@@ -4122,7 +4126,7 @@
         </p:nvCxnSpPr>
         <p:spPr>
           <a:xfrm flipV="1">
-            <a:off x="8637162" y="2402284"/>
+            <a:off x="8545722" y="1295860"/>
             <a:ext cx="680137" cy="1026854"/>
           </a:xfrm>
           <a:prstGeom prst="straightConnector1">
@@ -4167,7 +4171,7 @@
         </p:nvCxnSpPr>
         <p:spPr>
           <a:xfrm flipH="1" flipV="1">
-            <a:off x="7559491" y="2402284"/>
+            <a:off x="7468051" y="1295860"/>
             <a:ext cx="1679776" cy="285324"/>
           </a:xfrm>
           <a:prstGeom prst="straightConnector1">
@@ -4212,7 +4216,7 @@
         </p:nvCxnSpPr>
         <p:spPr>
           <a:xfrm flipH="1">
-            <a:off x="7988663" y="2698662"/>
+            <a:off x="7897223" y="1592238"/>
             <a:ext cx="1283804" cy="841622"/>
           </a:xfrm>
           <a:prstGeom prst="straightConnector1">
@@ -4258,7 +4262,7 @@
         </p:nvCxnSpPr>
         <p:spPr>
           <a:xfrm flipV="1">
-            <a:off x="8628964" y="2618642"/>
+            <a:off x="8537524" y="1512218"/>
             <a:ext cx="1306836" cy="960932"/>
           </a:xfrm>
           <a:prstGeom prst="bentConnector3">
@@ -4306,7 +4310,7 @@
         </p:nvCxnSpPr>
         <p:spPr>
           <a:xfrm rot="5400000" flipH="1">
-            <a:off x="7140932" y="2421069"/>
+            <a:off x="7049492" y="1314645"/>
             <a:ext cx="1111368" cy="1506515"/>
           </a:xfrm>
           <a:prstGeom prst="bentConnector4">
@@ -4354,7 +4358,7 @@
         </p:nvCxnSpPr>
         <p:spPr>
           <a:xfrm rot="16200000" flipH="1">
-            <a:off x="7265196" y="3119571"/>
+            <a:off x="7173756" y="2013147"/>
             <a:ext cx="863218" cy="537652"/>
           </a:xfrm>
           <a:prstGeom prst="bentConnector2">
@@ -4397,7 +4401,7 @@
         </p:nvCxnSpPr>
         <p:spPr>
           <a:xfrm rot="5400000" flipH="1" flipV="1">
-            <a:off x="8370816" y="1396083"/>
+            <a:off x="8279376" y="289659"/>
             <a:ext cx="316996" cy="2202670"/>
           </a:xfrm>
           <a:prstGeom prst="bentConnector3">
@@ -4441,7 +4445,7 @@
         </p:nvCxnSpPr>
         <p:spPr>
           <a:xfrm rot="5400000">
-            <a:off x="8593695" y="2970720"/>
+            <a:off x="8502255" y="1864296"/>
             <a:ext cx="831526" cy="867047"/>
           </a:xfrm>
           <a:prstGeom prst="bentConnector2">
@@ -4487,7 +4491,7 @@
         </p:nvCxnSpPr>
         <p:spPr>
           <a:xfrm rot="16200000" flipV="1">
-            <a:off x="8171402" y="1416028"/>
+            <a:off x="8079962" y="309604"/>
             <a:ext cx="348688" cy="2194471"/>
           </a:xfrm>
           <a:prstGeom prst="bentConnector3">
@@ -4531,7 +4535,7 @@
         </p:nvSpPr>
         <p:spPr>
           <a:xfrm>
-            <a:off x="3228675" y="3571794"/>
+            <a:off x="3137235" y="2465370"/>
             <a:ext cx="1362558" cy="461665"/>
           </a:xfrm>
           <a:prstGeom prst="rect">
@@ -4567,7 +4571,7 @@
         </p:nvSpPr>
         <p:spPr>
           <a:xfrm>
-            <a:off x="6450540" y="2125285"/>
+            <a:off x="6359100" y="1018861"/>
             <a:ext cx="916395" cy="276999"/>
           </a:xfrm>
           <a:prstGeom prst="rect">
@@ -4615,7 +4619,7 @@
         </p:nvSpPr>
         <p:spPr>
           <a:xfrm>
-            <a:off x="8529314" y="3859280"/>
+            <a:off x="8437874" y="2752856"/>
             <a:ext cx="916395" cy="276999"/>
           </a:xfrm>
           <a:prstGeom prst="rect">
@@ -4663,7 +4667,7 @@
         </p:nvSpPr>
         <p:spPr>
           <a:xfrm>
-            <a:off x="9686426" y="2122519"/>
+            <a:off x="9594986" y="1016095"/>
             <a:ext cx="916395" cy="276999"/>
           </a:xfrm>
           <a:prstGeom prst="rect">
@@ -4711,7 +4715,7 @@
         </p:nvSpPr>
         <p:spPr>
           <a:xfrm>
-            <a:off x="3020834" y="2137257"/>
+            <a:off x="2929394" y="1030833"/>
             <a:ext cx="1362558" cy="276999"/>
           </a:xfrm>
           <a:prstGeom prst="rect">
@@ -4747,7 +4751,7 @@
         </p:nvSpPr>
         <p:spPr>
           <a:xfrm>
-            <a:off x="5837827" y="1878607"/>
+            <a:off x="5746387" y="772183"/>
             <a:ext cx="1362558" cy="276999"/>
           </a:xfrm>
           <a:prstGeom prst="rect">
@@ -4785,7 +4789,7 @@
         </p:nvCxnSpPr>
         <p:spPr>
           <a:xfrm flipH="1">
-            <a:off x="1240606" y="3397186"/>
+            <a:off x="1149166" y="2290762"/>
             <a:ext cx="475626" cy="0"/>
           </a:xfrm>
           <a:prstGeom prst="straightConnector1">
@@ -4842,7 +4846,7 @@
         </p:blipFill>
         <p:spPr>
           <a:xfrm>
-            <a:off x="1264100" y="2330169"/>
+            <a:off x="1172660" y="1223745"/>
             <a:ext cx="438683" cy="368493"/>
           </a:xfrm>
           <a:prstGeom prst="rect">
@@ -4877,7 +4881,7 @@
         </p:blipFill>
         <p:spPr>
           <a:xfrm>
-            <a:off x="1226826" y="2783389"/>
+            <a:off x="1135386" y="1676965"/>
             <a:ext cx="503187" cy="461255"/>
           </a:xfrm>
           <a:prstGeom prst="rect">
@@ -4901,7 +4905,7 @@
         </p:nvCxnSpPr>
         <p:spPr>
           <a:xfrm flipH="1">
-            <a:off x="1254662" y="3607761"/>
+            <a:off x="1163222" y="2501337"/>
             <a:ext cx="475626" cy="0"/>
           </a:xfrm>
           <a:prstGeom prst="straightConnector1">
@@ -4944,7 +4948,7 @@
         </p:nvSpPr>
         <p:spPr>
           <a:xfrm rot="10800000" flipH="1">
-            <a:off x="1270395" y="3746564"/>
+            <a:off x="1178955" y="2640140"/>
             <a:ext cx="432387" cy="138697"/>
           </a:xfrm>
           <a:prstGeom prst="curvedDownArrow">
@@ -5000,7 +5004,7 @@
         </p:nvSpPr>
         <p:spPr>
           <a:xfrm>
-            <a:off x="1782237" y="2398044"/>
+            <a:off x="1690797" y="1291620"/>
             <a:ext cx="916395" cy="276999"/>
           </a:xfrm>
           <a:prstGeom prst="rect">
@@ -5048,7 +5052,7 @@
         </p:nvSpPr>
         <p:spPr>
           <a:xfrm>
-            <a:off x="1768710" y="2842474"/>
+            <a:off x="1677270" y="1736050"/>
             <a:ext cx="916395" cy="276999"/>
           </a:xfrm>
           <a:prstGeom prst="rect">
@@ -5096,7 +5100,7 @@
         </p:nvSpPr>
         <p:spPr>
           <a:xfrm>
-            <a:off x="1771075" y="3243153"/>
+            <a:off x="1679635" y="2136729"/>
             <a:ext cx="1101130" cy="276999"/>
           </a:xfrm>
           <a:prstGeom prst="rect">
@@ -5144,7 +5148,7 @@
         </p:nvSpPr>
         <p:spPr>
           <a:xfrm>
-            <a:off x="1777715" y="3511413"/>
+            <a:off x="1686275" y="2404989"/>
             <a:ext cx="1101130" cy="461665"/>
           </a:xfrm>
           <a:prstGeom prst="rect">
@@ -5192,7 +5196,7 @@
         </p:nvSpPr>
         <p:spPr>
           <a:xfrm>
-            <a:off x="821062" y="1606048"/>
+            <a:off x="729622" y="499624"/>
             <a:ext cx="9695565" cy="2540876"/>
           </a:xfrm>
           <a:prstGeom prst="rect">
@@ -5246,7 +5250,7 @@
         </p:nvSpPr>
         <p:spPr>
           <a:xfrm>
-            <a:off x="937505" y="1663452"/>
+            <a:off x="846065" y="557028"/>
             <a:ext cx="3089139" cy="369332"/>
           </a:xfrm>
           <a:prstGeom prst="rect">
@@ -5268,36 +5272,6 @@
           </a:p>
         </p:txBody>
       </p:sp>
-    </p:spTree>
-    <p:extLst>
-      <p:ext uri="{BB962C8B-B14F-4D97-AF65-F5344CB8AC3E}">
-        <p14:creationId xmlns:p14="http://schemas.microsoft.com/office/powerpoint/2010/main" val="1817311260"/>
-      </p:ext>
-    </p:extLst>
-  </p:cSld>
-  <p:clrMapOvr>
-    <a:masterClrMapping/>
-  </p:clrMapOvr>
-</p:sld>
-</file>
-
-<file path=ppt/slides/slide2.xml><?xml version="1.0" encoding="utf-8"?>
-<p:sld xmlns:a="http://schemas.openxmlformats.org/drawingml/2006/main" xmlns:r="http://schemas.openxmlformats.org/officeDocument/2006/relationships" xmlns:p="http://schemas.openxmlformats.org/presentationml/2006/main">
-  <p:cSld>
-    <p:spTree>
-      <p:nvGrpSpPr>
-        <p:cNvPr id="1" name=""/>
-        <p:cNvGrpSpPr/>
-        <p:nvPr/>
-      </p:nvGrpSpPr>
-      <p:grpSpPr>
-        <a:xfrm>
-          <a:off x="0" y="0"/>
-          <a:ext cx="0" cy="0"/>
-          <a:chOff x="0" y="0"/>
-          <a:chExt cx="0" cy="0"/>
-        </a:xfrm>
-      </p:grpSpPr>
       <p:pic>
         <p:nvPicPr>
           <p:cNvPr id="4" name="Picture 3" descr="A dog and shield with eye and shield symbol&#10;&#10;Description automatically generated">
@@ -5313,7 +5287,7 @@
           <p:nvPr/>
         </p:nvPicPr>
         <p:blipFill>
-          <a:blip r:embed="rId2">
+          <a:blip r:embed="rId3">
             <a:extLst>
               <a:ext uri="{28A0092B-C50C-407E-A947-70E740481C1C}">
                 <a14:useLocalDpi xmlns:a14="http://schemas.microsoft.com/office/drawing/2010/main" val="0"/>
@@ -5326,7 +5300,7 @@
         </p:blipFill>
         <p:spPr>
           <a:xfrm>
-            <a:off x="632137" y="3699430"/>
+            <a:off x="655581" y="4559940"/>
             <a:ext cx="438683" cy="368493"/>
           </a:xfrm>
           <a:prstGeom prst="rect">
@@ -5341,7 +5315,7 @@
       </p:pic>
       <p:pic>
         <p:nvPicPr>
-          <p:cNvPr id="5" name="Picture 2" descr="Document, file, record, recording icon - Download on Iconfinder">
+          <p:cNvPr id="2" name="Picture 2" descr="Document, file, record, recording icon - Download on Iconfinder">
             <a:extLst>
               <a:ext uri="{FF2B5EF4-FFF2-40B4-BE49-F238E27FC236}">
                 <a16:creationId xmlns:a16="http://schemas.microsoft.com/office/drawing/2014/main" id="{D70A3703-7FB2-7DD5-311D-60EB0E7E2567}"/>
@@ -5354,7 +5328,7 @@
           <p:nvPr/>
         </p:nvPicPr>
         <p:blipFill>
-          <a:blip r:embed="rId3">
+          <a:blip r:embed="rId4">
             <a:extLst>
               <a:ext uri="{28A0092B-C50C-407E-A947-70E740481C1C}">
                 <a14:useLocalDpi xmlns:a14="http://schemas.microsoft.com/office/drawing/2010/main" val="0"/>
@@ -5368,7 +5342,7 @@
         </p:blipFill>
         <p:spPr bwMode="auto">
           <a:xfrm>
-            <a:off x="632136" y="4283368"/>
+            <a:off x="655580" y="5143878"/>
             <a:ext cx="438683" cy="438683"/>
           </a:xfrm>
           <a:prstGeom prst="rect">
@@ -5388,7 +5362,7 @@
       </p:pic>
       <p:cxnSp>
         <p:nvCxnSpPr>
-          <p:cNvPr id="7" name="Straight Arrow Connector 6">
+          <p:cNvPr id="3" name="Straight Arrow Connector 2">
             <a:extLst>
               <a:ext uri="{FF2B5EF4-FFF2-40B4-BE49-F238E27FC236}">
                 <a16:creationId xmlns:a16="http://schemas.microsoft.com/office/drawing/2014/main" id="{CFF7A4CD-335F-3D11-9D50-88020625A205}"/>
@@ -5397,13 +5371,13 @@
           </p:cNvPr>
           <p:cNvCxnSpPr>
             <a:stCxn id="4" idx="2"/>
-            <a:endCxn id="5" idx="0"/>
+            <a:endCxn id="2" idx="0"/>
           </p:cNvCxnSpPr>
           <p:nvPr/>
         </p:nvCxnSpPr>
         <p:spPr>
           <a:xfrm flipH="1">
-            <a:off x="851478" y="4067923"/>
+            <a:off x="874922" y="4928433"/>
             <a:ext cx="1" cy="215445"/>
           </a:xfrm>
           <a:prstGeom prst="straightConnector1">
@@ -5433,7 +5407,7 @@
       </p:cxnSp>
       <p:cxnSp>
         <p:nvCxnSpPr>
-          <p:cNvPr id="9" name="Straight Arrow Connector 8">
+          <p:cNvPr id="49" name="Straight Arrow Connector 48">
             <a:extLst>
               <a:ext uri="{FF2B5EF4-FFF2-40B4-BE49-F238E27FC236}">
                 <a16:creationId xmlns:a16="http://schemas.microsoft.com/office/drawing/2014/main" id="{4E1E7382-5476-176D-3F61-EE41F5914198}"/>
@@ -5447,7 +5421,7 @@
         </p:nvCxnSpPr>
         <p:spPr>
           <a:xfrm>
-            <a:off x="1070819" y="3883676"/>
+            <a:off x="1094263" y="4744186"/>
             <a:ext cx="453021" cy="0"/>
           </a:xfrm>
           <a:prstGeom prst="straightConnector1">
@@ -5475,7 +5449,7 @@
       </p:cxnSp>
       <p:pic>
         <p:nvPicPr>
-          <p:cNvPr id="19" name="Picture 18" descr="A dog and shield with eye and shield symbol&#10;&#10;Description automatically generated">
+          <p:cNvPr id="50" name="Picture 49" descr="A dog and shield with eye and shield symbol&#10;&#10;Description automatically generated">
             <a:extLst>
               <a:ext uri="{FF2B5EF4-FFF2-40B4-BE49-F238E27FC236}">
                 <a16:creationId xmlns:a16="http://schemas.microsoft.com/office/drawing/2014/main" id="{182D6C7C-A18B-1724-D10E-AAF42046B5AC}"/>
@@ -5488,7 +5462,7 @@
           <p:nvPr/>
         </p:nvPicPr>
         <p:blipFill>
-          <a:blip r:embed="rId2">
+          <a:blip r:embed="rId3">
             <a:extLst>
               <a:ext uri="{28A0092B-C50C-407E-A947-70E740481C1C}">
                 <a14:useLocalDpi xmlns:a14="http://schemas.microsoft.com/office/drawing/2010/main" val="0"/>
@@ -5501,7 +5475,7 @@
         </p:blipFill>
         <p:spPr>
           <a:xfrm>
-            <a:off x="1524925" y="3699429"/>
+            <a:off x="1548369" y="4559939"/>
             <a:ext cx="438683" cy="368493"/>
           </a:xfrm>
           <a:prstGeom prst="rect">
@@ -5516,7 +5490,7 @@
       </p:pic>
       <p:pic>
         <p:nvPicPr>
-          <p:cNvPr id="20" name="Picture 2" descr="Document, file, record, recording icon - Download on Iconfinder">
+          <p:cNvPr id="51" name="Picture 2" descr="Document, file, record, recording icon - Download on Iconfinder">
             <a:extLst>
               <a:ext uri="{FF2B5EF4-FFF2-40B4-BE49-F238E27FC236}">
                 <a16:creationId xmlns:a16="http://schemas.microsoft.com/office/drawing/2014/main" id="{0D1DBA7C-7272-40A9-186E-D06D1CEFE7B8}"/>
@@ -5529,7 +5503,7 @@
           <p:nvPr/>
         </p:nvPicPr>
         <p:blipFill>
-          <a:blip r:embed="rId3">
+          <a:blip r:embed="rId4">
             <a:extLst>
               <a:ext uri="{28A0092B-C50C-407E-A947-70E740481C1C}">
                 <a14:useLocalDpi xmlns:a14="http://schemas.microsoft.com/office/drawing/2010/main" val="0"/>
@@ -5543,7 +5517,7 @@
         </p:blipFill>
         <p:spPr bwMode="auto">
           <a:xfrm>
-            <a:off x="1524924" y="4252168"/>
+            <a:off x="1548368" y="5112678"/>
             <a:ext cx="438683" cy="438683"/>
           </a:xfrm>
           <a:prstGeom prst="rect">
@@ -5563,7 +5537,7 @@
       </p:pic>
       <p:cxnSp>
         <p:nvCxnSpPr>
-          <p:cNvPr id="21" name="Straight Arrow Connector 20">
+          <p:cNvPr id="52" name="Straight Arrow Connector 51">
             <a:extLst>
               <a:ext uri="{FF2B5EF4-FFF2-40B4-BE49-F238E27FC236}">
                 <a16:creationId xmlns:a16="http://schemas.microsoft.com/office/drawing/2014/main" id="{2B4D6CFF-23E7-A447-446F-1C3E8FAE4C0B}"/>
@@ -5571,14 +5545,14 @@
             </a:extLst>
           </p:cNvPr>
           <p:cNvCxnSpPr>
-            <a:stCxn id="19" idx="2"/>
-            <a:endCxn id="20" idx="0"/>
+            <a:stCxn id="50" idx="2"/>
+            <a:endCxn id="51" idx="0"/>
           </p:cNvCxnSpPr>
           <p:nvPr/>
         </p:nvCxnSpPr>
         <p:spPr>
           <a:xfrm flipH="1">
-            <a:off x="1744266" y="4067922"/>
+            <a:off x="1767710" y="4928432"/>
             <a:ext cx="1" cy="184246"/>
           </a:xfrm>
           <a:prstGeom prst="straightConnector1">
@@ -5608,7 +5582,7 @@
       </p:cxnSp>
       <p:cxnSp>
         <p:nvCxnSpPr>
-          <p:cNvPr id="22" name="Straight Arrow Connector 21">
+          <p:cNvPr id="53" name="Straight Arrow Connector 52">
             <a:extLst>
               <a:ext uri="{FF2B5EF4-FFF2-40B4-BE49-F238E27FC236}">
                 <a16:creationId xmlns:a16="http://schemas.microsoft.com/office/drawing/2014/main" id="{004E7AE4-4D20-FE1B-C40C-C84FF9052970}"/>
@@ -5622,7 +5596,7 @@
         </p:nvCxnSpPr>
         <p:spPr>
           <a:xfrm>
-            <a:off x="1963607" y="3883675"/>
+            <a:off x="1987051" y="4744185"/>
             <a:ext cx="453021" cy="0"/>
           </a:xfrm>
           <a:prstGeom prst="straightConnector1">
@@ -5650,7 +5624,7 @@
       </p:cxnSp>
       <p:pic>
         <p:nvPicPr>
-          <p:cNvPr id="24" name="Picture 23" descr="A dog and shield with eye and shield symbol&#10;&#10;Description automatically generated">
+          <p:cNvPr id="54" name="Picture 53" descr="A dog and shield with eye and shield symbol&#10;&#10;Description automatically generated">
             <a:extLst>
               <a:ext uri="{FF2B5EF4-FFF2-40B4-BE49-F238E27FC236}">
                 <a16:creationId xmlns:a16="http://schemas.microsoft.com/office/drawing/2014/main" id="{075C0B0B-A735-F9BA-FB74-A2BBE317C298}"/>
@@ -5663,7 +5637,7 @@
           <p:nvPr/>
         </p:nvPicPr>
         <p:blipFill>
-          <a:blip r:embed="rId2">
+          <a:blip r:embed="rId3">
             <a:extLst>
               <a:ext uri="{28A0092B-C50C-407E-A947-70E740481C1C}">
                 <a14:useLocalDpi xmlns:a14="http://schemas.microsoft.com/office/drawing/2010/main" val="0"/>
@@ -5676,7 +5650,7 @@
         </p:blipFill>
         <p:spPr>
           <a:xfrm>
-            <a:off x="2417711" y="3699430"/>
+            <a:off x="2441155" y="4559940"/>
             <a:ext cx="438683" cy="368493"/>
           </a:xfrm>
           <a:prstGeom prst="rect">
@@ -5691,7 +5665,7 @@
       </p:pic>
       <p:pic>
         <p:nvPicPr>
-          <p:cNvPr id="25" name="Picture 2" descr="Document, file, record, recording icon - Download on Iconfinder">
+          <p:cNvPr id="55" name="Picture 2" descr="Document, file, record, recording icon - Download on Iconfinder">
             <a:extLst>
               <a:ext uri="{FF2B5EF4-FFF2-40B4-BE49-F238E27FC236}">
                 <a16:creationId xmlns:a16="http://schemas.microsoft.com/office/drawing/2014/main" id="{E93FE926-24D8-5288-FD0D-6FFF6B6CA0F5}"/>
@@ -5704,7 +5678,7 @@
           <p:nvPr/>
         </p:nvPicPr>
         <p:blipFill>
-          <a:blip r:embed="rId3">
+          <a:blip r:embed="rId4">
             <a:extLst>
               <a:ext uri="{28A0092B-C50C-407E-A947-70E740481C1C}">
                 <a14:useLocalDpi xmlns:a14="http://schemas.microsoft.com/office/drawing/2010/main" val="0"/>
@@ -5718,7 +5692,7 @@
         </p:blipFill>
         <p:spPr bwMode="auto">
           <a:xfrm>
-            <a:off x="2417710" y="4283368"/>
+            <a:off x="2441154" y="5143878"/>
             <a:ext cx="438683" cy="438683"/>
           </a:xfrm>
           <a:prstGeom prst="rect">
@@ -5738,7 +5712,7 @@
       </p:pic>
       <p:cxnSp>
         <p:nvCxnSpPr>
-          <p:cNvPr id="26" name="Straight Arrow Connector 25">
+          <p:cNvPr id="56" name="Straight Arrow Connector 55">
             <a:extLst>
               <a:ext uri="{FF2B5EF4-FFF2-40B4-BE49-F238E27FC236}">
                 <a16:creationId xmlns:a16="http://schemas.microsoft.com/office/drawing/2014/main" id="{476C89D3-2897-ECB3-F335-0B088FD5BF90}"/>
@@ -5746,14 +5720,14 @@
             </a:extLst>
           </p:cNvPr>
           <p:cNvCxnSpPr>
-            <a:stCxn id="24" idx="2"/>
-            <a:endCxn id="25" idx="0"/>
+            <a:stCxn id="54" idx="2"/>
+            <a:endCxn id="55" idx="0"/>
           </p:cNvCxnSpPr>
           <p:nvPr/>
         </p:nvCxnSpPr>
         <p:spPr>
           <a:xfrm flipH="1">
-            <a:off x="2637052" y="4067923"/>
+            <a:off x="2660496" y="4928433"/>
             <a:ext cx="1" cy="215445"/>
           </a:xfrm>
           <a:prstGeom prst="straightConnector1">
@@ -5783,7 +5757,7 @@
       </p:cxnSp>
       <p:cxnSp>
         <p:nvCxnSpPr>
-          <p:cNvPr id="27" name="Straight Arrow Connector 26">
+          <p:cNvPr id="57" name="Straight Arrow Connector 56">
             <a:extLst>
               <a:ext uri="{FF2B5EF4-FFF2-40B4-BE49-F238E27FC236}">
                 <a16:creationId xmlns:a16="http://schemas.microsoft.com/office/drawing/2014/main" id="{20FD41FE-7686-A6D9-EE8B-DB3CF78C6D1E}"/>
@@ -5797,7 +5771,7 @@
         </p:nvCxnSpPr>
         <p:spPr>
           <a:xfrm>
-            <a:off x="2856393" y="3883676"/>
+            <a:off x="2879837" y="4744186"/>
             <a:ext cx="453021" cy="0"/>
           </a:xfrm>
           <a:prstGeom prst="straightConnector1">
@@ -5825,7 +5799,7 @@
       </p:cxnSp>
       <p:pic>
         <p:nvPicPr>
-          <p:cNvPr id="28" name="Picture 27" descr="A dog and shield with eye and shield symbol&#10;&#10;Description automatically generated">
+          <p:cNvPr id="58" name="Picture 57" descr="A dog and shield with eye and shield symbol&#10;&#10;Description automatically generated">
             <a:extLst>
               <a:ext uri="{FF2B5EF4-FFF2-40B4-BE49-F238E27FC236}">
                 <a16:creationId xmlns:a16="http://schemas.microsoft.com/office/drawing/2014/main" id="{01B7FEC5-31E4-E96A-F941-6B9BC6FCCDD0}"/>
@@ -5838,7 +5812,7 @@
           <p:nvPr/>
         </p:nvPicPr>
         <p:blipFill>
-          <a:blip r:embed="rId2">
+          <a:blip r:embed="rId3">
             <a:extLst>
               <a:ext uri="{28A0092B-C50C-407E-A947-70E740481C1C}">
                 <a14:useLocalDpi xmlns:a14="http://schemas.microsoft.com/office/drawing/2010/main" val="0"/>
@@ -5851,7 +5825,7 @@
         </p:blipFill>
         <p:spPr>
           <a:xfrm>
-            <a:off x="3310496" y="3699428"/>
+            <a:off x="3333940" y="4559938"/>
             <a:ext cx="438683" cy="368493"/>
           </a:xfrm>
           <a:prstGeom prst="rect">
@@ -5866,7 +5840,7 @@
       </p:pic>
       <p:cxnSp>
         <p:nvCxnSpPr>
-          <p:cNvPr id="29" name="Straight Arrow Connector 28">
+          <p:cNvPr id="59" name="Straight Arrow Connector 58">
             <a:extLst>
               <a:ext uri="{FF2B5EF4-FFF2-40B4-BE49-F238E27FC236}">
                 <a16:creationId xmlns:a16="http://schemas.microsoft.com/office/drawing/2014/main" id="{60699A96-BA41-FE9A-7429-280E045D53D3}"/>
@@ -5878,7 +5852,7 @@
         </p:nvCxnSpPr>
         <p:spPr>
           <a:xfrm flipH="1">
-            <a:off x="3478493" y="4067923"/>
+            <a:off x="3501937" y="4928433"/>
             <a:ext cx="1" cy="215445"/>
           </a:xfrm>
           <a:prstGeom prst="straightConnector1">
@@ -5908,7 +5882,7 @@
       </p:cxnSp>
       <p:pic>
         <p:nvPicPr>
-          <p:cNvPr id="30" name="Picture 2" descr="Document, file, record, recording icon - Download on Iconfinder">
+          <p:cNvPr id="60" name="Picture 2" descr="Document, file, record, recording icon - Download on Iconfinder">
             <a:extLst>
               <a:ext uri="{FF2B5EF4-FFF2-40B4-BE49-F238E27FC236}">
                 <a16:creationId xmlns:a16="http://schemas.microsoft.com/office/drawing/2014/main" id="{B6A95AB6-A706-A342-CDF4-AC64BE2CC55E}"/>
@@ -5921,7 +5895,7 @@
           <p:nvPr/>
         </p:nvPicPr>
         <p:blipFill>
-          <a:blip r:embed="rId3">
+          <a:blip r:embed="rId4">
             <a:extLst>
               <a:ext uri="{28A0092B-C50C-407E-A947-70E740481C1C}">
                 <a14:useLocalDpi xmlns:a14="http://schemas.microsoft.com/office/drawing/2010/main" val="0"/>
@@ -5935,7 +5909,7 @@
         </p:blipFill>
         <p:spPr bwMode="auto">
           <a:xfrm>
-            <a:off x="3309414" y="4259572"/>
+            <a:off x="3332858" y="5120082"/>
             <a:ext cx="438683" cy="438683"/>
           </a:xfrm>
           <a:prstGeom prst="rect">
@@ -5955,7 +5929,7 @@
       </p:pic>
       <p:cxnSp>
         <p:nvCxnSpPr>
-          <p:cNvPr id="32" name="Connector: Elbow 31">
+          <p:cNvPr id="61" name="Connector: Elbow 60">
             <a:extLst>
               <a:ext uri="{FF2B5EF4-FFF2-40B4-BE49-F238E27FC236}">
                 <a16:creationId xmlns:a16="http://schemas.microsoft.com/office/drawing/2014/main" id="{8A116FEE-E2EB-15FF-0A4A-ACCA6B3847C8}"/>
@@ -5963,14 +5937,14 @@
             </a:extLst>
           </p:cNvPr>
           <p:cNvCxnSpPr>
-            <a:stCxn id="28" idx="0"/>
+            <a:stCxn id="58" idx="0"/>
             <a:endCxn id="4" idx="0"/>
           </p:cNvCxnSpPr>
           <p:nvPr/>
         </p:nvCxnSpPr>
         <p:spPr>
           <a:xfrm rot="16200000" flipH="1" flipV="1">
-            <a:off x="2190658" y="2360249"/>
+            <a:off x="2214102" y="3220759"/>
             <a:ext cx="2" cy="2678359"/>
           </a:xfrm>
           <a:prstGeom prst="bentConnector3">
@@ -6000,7 +5974,7 @@
       </p:cxnSp>
       <p:pic>
         <p:nvPicPr>
-          <p:cNvPr id="33" name="Picture 32" descr="A dog and shield with eye and shield symbol&#10;&#10;Description automatically generated">
+          <p:cNvPr id="62" name="Picture 61" descr="A dog and shield with eye and shield symbol&#10;&#10;Description automatically generated">
             <a:extLst>
               <a:ext uri="{FF2B5EF4-FFF2-40B4-BE49-F238E27FC236}">
                 <a16:creationId xmlns:a16="http://schemas.microsoft.com/office/drawing/2014/main" id="{39FCD3F2-11CD-CF7B-83E0-7271FDF7F598}"/>
@@ -6013,7 +5987,7 @@
           <p:nvPr/>
         </p:nvPicPr>
         <p:blipFill>
-          <a:blip r:embed="rId2">
+          <a:blip r:embed="rId3">
             <a:extLst>
               <a:ext uri="{28A0092B-C50C-407E-A947-70E740481C1C}">
                 <a14:useLocalDpi xmlns:a14="http://schemas.microsoft.com/office/drawing/2010/main" val="0"/>
@@ -6026,7 +6000,7 @@
         </p:blipFill>
         <p:spPr>
           <a:xfrm>
-            <a:off x="4420459" y="4138358"/>
+            <a:off x="4443903" y="4998868"/>
             <a:ext cx="438683" cy="368493"/>
           </a:xfrm>
           <a:prstGeom prst="rect">
@@ -6041,7 +6015,7 @@
       </p:pic>
       <p:pic>
         <p:nvPicPr>
-          <p:cNvPr id="34" name="Picture 33" descr="A dog and shield with eye and shield symbol&#10;&#10;Description automatically generated">
+          <p:cNvPr id="63" name="Picture 62" descr="A dog and shield with eye and shield symbol&#10;&#10;Description automatically generated">
             <a:extLst>
               <a:ext uri="{FF2B5EF4-FFF2-40B4-BE49-F238E27FC236}">
                 <a16:creationId xmlns:a16="http://schemas.microsoft.com/office/drawing/2014/main" id="{E6FF16DD-5712-C978-F062-B8F31A23A51D}"/>
@@ -6054,7 +6028,7 @@
           <p:nvPr/>
         </p:nvPicPr>
         <p:blipFill>
-          <a:blip r:embed="rId2">
+          <a:blip r:embed="rId3">
             <a:extLst>
               <a:ext uri="{28A0092B-C50C-407E-A947-70E740481C1C}">
                 <a14:useLocalDpi xmlns:a14="http://schemas.microsoft.com/office/drawing/2010/main" val="0"/>
@@ -6067,7 +6041,7 @@
         </p:blipFill>
         <p:spPr>
           <a:xfrm>
-            <a:off x="5383555" y="3505789"/>
+            <a:off x="5406999" y="4366299"/>
             <a:ext cx="438683" cy="368493"/>
           </a:xfrm>
           <a:prstGeom prst="rect">
@@ -6082,7 +6056,7 @@
       </p:pic>
       <p:pic>
         <p:nvPicPr>
-          <p:cNvPr id="35" name="Picture 34" descr="A dog and shield with eye and shield symbol&#10;&#10;Description automatically generated">
+          <p:cNvPr id="64" name="Picture 63" descr="A dog and shield with eye and shield symbol&#10;&#10;Description automatically generated">
             <a:extLst>
               <a:ext uri="{FF2B5EF4-FFF2-40B4-BE49-F238E27FC236}">
                 <a16:creationId xmlns:a16="http://schemas.microsoft.com/office/drawing/2014/main" id="{B830D166-7007-FF83-C4FC-C8EBA7FA91E0}"/>
@@ -6095,7 +6069,7 @@
           <p:nvPr/>
         </p:nvPicPr>
         <p:blipFill>
-          <a:blip r:embed="rId2">
+          <a:blip r:embed="rId3">
             <a:extLst>
               <a:ext uri="{28A0092B-C50C-407E-A947-70E740481C1C}">
                 <a14:useLocalDpi xmlns:a14="http://schemas.microsoft.com/office/drawing/2010/main" val="0"/>
@@ -6108,7 +6082,7 @@
         </p:blipFill>
         <p:spPr>
           <a:xfrm>
-            <a:off x="5383556" y="4804660"/>
+            <a:off x="5407000" y="5665170"/>
             <a:ext cx="438683" cy="368493"/>
           </a:xfrm>
           <a:prstGeom prst="rect">
@@ -6123,7 +6097,7 @@
       </p:pic>
       <p:pic>
         <p:nvPicPr>
-          <p:cNvPr id="36" name="Picture 35" descr="A dog and shield with eye and shield symbol&#10;&#10;Description automatically generated">
+          <p:cNvPr id="65" name="Picture 64" descr="A dog and shield with eye and shield symbol&#10;&#10;Description automatically generated">
             <a:extLst>
               <a:ext uri="{FF2B5EF4-FFF2-40B4-BE49-F238E27FC236}">
                 <a16:creationId xmlns:a16="http://schemas.microsoft.com/office/drawing/2014/main" id="{3215E3F8-5B71-EEFC-8CBB-DDDA9DD2C21C}"/>
@@ -6136,7 +6110,7 @@
           <p:nvPr/>
         </p:nvPicPr>
         <p:blipFill>
-          <a:blip r:embed="rId2">
+          <a:blip r:embed="rId3">
             <a:extLst>
               <a:ext uri="{28A0092B-C50C-407E-A947-70E740481C1C}">
                 <a14:useLocalDpi xmlns:a14="http://schemas.microsoft.com/office/drawing/2010/main" val="0"/>
@@ -6149,7 +6123,7 @@
         </p:blipFill>
         <p:spPr>
           <a:xfrm>
-            <a:off x="6293062" y="4122073"/>
+            <a:off x="6316506" y="4982583"/>
             <a:ext cx="438683" cy="368493"/>
           </a:xfrm>
           <a:prstGeom prst="rect">
@@ -6164,7 +6138,7 @@
       </p:pic>
       <p:cxnSp>
         <p:nvCxnSpPr>
-          <p:cNvPr id="37" name="Straight Arrow Connector 36">
+          <p:cNvPr id="66" name="Straight Arrow Connector 65">
             <a:extLst>
               <a:ext uri="{FF2B5EF4-FFF2-40B4-BE49-F238E27FC236}">
                 <a16:creationId xmlns:a16="http://schemas.microsoft.com/office/drawing/2014/main" id="{24B4EDFD-9294-8487-12FF-E72DC392AD0E}"/>
@@ -6173,13 +6147,13 @@
           </p:cNvPr>
           <p:cNvCxnSpPr>
             <a:cxnSpLocks/>
-            <a:endCxn id="36" idx="1"/>
+            <a:endCxn id="65" idx="1"/>
           </p:cNvCxnSpPr>
           <p:nvPr/>
         </p:nvCxnSpPr>
         <p:spPr>
           <a:xfrm flipV="1">
-            <a:off x="4859142" y="4306320"/>
+            <a:off x="4882586" y="5166830"/>
             <a:ext cx="1433920" cy="4266"/>
           </a:xfrm>
           <a:prstGeom prst="straightConnector1">
@@ -6207,7 +6181,7 @@
       </p:cxnSp>
       <p:cxnSp>
         <p:nvCxnSpPr>
-          <p:cNvPr id="39" name="Straight Arrow Connector 38">
+          <p:cNvPr id="67" name="Straight Arrow Connector 66">
             <a:extLst>
               <a:ext uri="{FF2B5EF4-FFF2-40B4-BE49-F238E27FC236}">
                 <a16:creationId xmlns:a16="http://schemas.microsoft.com/office/drawing/2014/main" id="{6BFE5890-CDE7-C9CD-E975-0F7D93CEA2FF}"/>
@@ -6216,317 +6190,15 @@
           </p:cNvPr>
           <p:cNvCxnSpPr>
             <a:cxnSpLocks/>
-            <a:stCxn id="33" idx="3"/>
-            <a:endCxn id="35" idx="1"/>
+            <a:stCxn id="62" idx="3"/>
+            <a:endCxn id="64" idx="1"/>
           </p:cNvCxnSpPr>
           <p:nvPr/>
         </p:nvCxnSpPr>
         <p:spPr>
           <a:xfrm>
-            <a:off x="4859142" y="4322605"/>
+            <a:off x="4882586" y="5183115"/>
             <a:ext cx="524414" cy="666302"/>
-          </a:xfrm>
-          <a:prstGeom prst="straightConnector1">
-            <a:avLst/>
-          </a:prstGeom>
-          <a:ln w="19050">
-            <a:prstDash val="sysDash"/>
-            <a:tailEnd type="triangle"/>
-          </a:ln>
-        </p:spPr>
-        <p:style>
-          <a:lnRef idx="1">
-            <a:schemeClr val="accent1"/>
-          </a:lnRef>
-          <a:fillRef idx="0">
-            <a:schemeClr val="accent1"/>
-          </a:fillRef>
-          <a:effectRef idx="0">
-            <a:schemeClr val="accent1"/>
-          </a:effectRef>
-          <a:fontRef idx="minor">
-            <a:schemeClr val="tx1"/>
-          </a:fontRef>
-        </p:style>
-      </p:cxnSp>
-      <p:cxnSp>
-        <p:nvCxnSpPr>
-          <p:cNvPr id="43" name="Straight Arrow Connector 42">
-            <a:extLst>
-              <a:ext uri="{FF2B5EF4-FFF2-40B4-BE49-F238E27FC236}">
-                <a16:creationId xmlns:a16="http://schemas.microsoft.com/office/drawing/2014/main" id="{68926775-101E-4F5D-D026-CA6FE51932B1}"/>
-              </a:ext>
-            </a:extLst>
-          </p:cNvPr>
-          <p:cNvCxnSpPr>
-            <a:cxnSpLocks/>
-            <a:stCxn id="33" idx="3"/>
-            <a:endCxn id="34" idx="1"/>
-          </p:cNvCxnSpPr>
-          <p:nvPr/>
-        </p:nvCxnSpPr>
-        <p:spPr>
-          <a:xfrm flipV="1">
-            <a:off x="4859142" y="3690036"/>
-            <a:ext cx="524413" cy="632569"/>
-          </a:xfrm>
-          <a:prstGeom prst="straightConnector1">
-            <a:avLst/>
-          </a:prstGeom>
-          <a:ln w="19050">
-            <a:prstDash val="sysDash"/>
-            <a:tailEnd type="triangle"/>
-          </a:ln>
-        </p:spPr>
-        <p:style>
-          <a:lnRef idx="1">
-            <a:schemeClr val="accent1"/>
-          </a:lnRef>
-          <a:fillRef idx="0">
-            <a:schemeClr val="accent1"/>
-          </a:fillRef>
-          <a:effectRef idx="0">
-            <a:schemeClr val="accent1"/>
-          </a:effectRef>
-          <a:fontRef idx="minor">
-            <a:schemeClr val="tx1"/>
-          </a:fontRef>
-        </p:style>
-      </p:cxnSp>
-      <p:cxnSp>
-        <p:nvCxnSpPr>
-          <p:cNvPr id="46" name="Straight Arrow Connector 45">
-            <a:extLst>
-              <a:ext uri="{FF2B5EF4-FFF2-40B4-BE49-F238E27FC236}">
-                <a16:creationId xmlns:a16="http://schemas.microsoft.com/office/drawing/2014/main" id="{4AC9BA77-F308-7AD6-97FC-475E8A512E8A}"/>
-              </a:ext>
-            </a:extLst>
-          </p:cNvPr>
-          <p:cNvCxnSpPr>
-            <a:cxnSpLocks/>
-            <a:stCxn id="34" idx="2"/>
-            <a:endCxn id="35" idx="0"/>
-          </p:cNvCxnSpPr>
-          <p:nvPr/>
-        </p:nvCxnSpPr>
-        <p:spPr>
-          <a:xfrm>
-            <a:off x="5602897" y="3874282"/>
-            <a:ext cx="1" cy="930378"/>
-          </a:xfrm>
-          <a:prstGeom prst="straightConnector1">
-            <a:avLst/>
-          </a:prstGeom>
-          <a:ln w="19050">
-            <a:prstDash val="sysDash"/>
-            <a:tailEnd type="triangle"/>
-          </a:ln>
-        </p:spPr>
-        <p:style>
-          <a:lnRef idx="1">
-            <a:schemeClr val="accent1"/>
-          </a:lnRef>
-          <a:fillRef idx="0">
-            <a:schemeClr val="accent1"/>
-          </a:fillRef>
-          <a:effectRef idx="0">
-            <a:schemeClr val="accent1"/>
-          </a:effectRef>
-          <a:fontRef idx="minor">
-            <a:schemeClr val="tx1"/>
-          </a:fontRef>
-        </p:style>
-      </p:cxnSp>
-      <p:cxnSp>
-        <p:nvCxnSpPr>
-          <p:cNvPr id="49" name="Straight Arrow Connector 48">
-            <a:extLst>
-              <a:ext uri="{FF2B5EF4-FFF2-40B4-BE49-F238E27FC236}">
-                <a16:creationId xmlns:a16="http://schemas.microsoft.com/office/drawing/2014/main" id="{62C510E6-A13B-A2E1-BA11-B73120B80C33}"/>
-              </a:ext>
-            </a:extLst>
-          </p:cNvPr>
-          <p:cNvCxnSpPr>
-            <a:cxnSpLocks/>
-            <a:stCxn id="34" idx="3"/>
-            <a:endCxn id="36" idx="0"/>
-          </p:cNvCxnSpPr>
-          <p:nvPr/>
-        </p:nvCxnSpPr>
-        <p:spPr>
-          <a:xfrm>
-            <a:off x="5822238" y="3690036"/>
-            <a:ext cx="690166" cy="432037"/>
-          </a:xfrm>
-          <a:prstGeom prst="straightConnector1">
-            <a:avLst/>
-          </a:prstGeom>
-          <a:ln w="19050">
-            <a:prstDash val="sysDash"/>
-            <a:tailEnd type="triangle"/>
-          </a:ln>
-        </p:spPr>
-        <p:style>
-          <a:lnRef idx="1">
-            <a:schemeClr val="accent1"/>
-          </a:lnRef>
-          <a:fillRef idx="0">
-            <a:schemeClr val="accent1"/>
-          </a:fillRef>
-          <a:effectRef idx="0">
-            <a:schemeClr val="accent1"/>
-          </a:effectRef>
-          <a:fontRef idx="minor">
-            <a:schemeClr val="tx1"/>
-          </a:fontRef>
-        </p:style>
-      </p:cxnSp>
-      <p:cxnSp>
-        <p:nvCxnSpPr>
-          <p:cNvPr id="52" name="Straight Arrow Connector 51">
-            <a:extLst>
-              <a:ext uri="{FF2B5EF4-FFF2-40B4-BE49-F238E27FC236}">
-                <a16:creationId xmlns:a16="http://schemas.microsoft.com/office/drawing/2014/main" id="{6DECD70B-86BE-0869-7A87-D6847A03585F}"/>
-              </a:ext>
-            </a:extLst>
-          </p:cNvPr>
-          <p:cNvCxnSpPr>
-            <a:cxnSpLocks/>
-            <a:stCxn id="35" idx="3"/>
-            <a:endCxn id="36" idx="2"/>
-          </p:cNvCxnSpPr>
-          <p:nvPr/>
-        </p:nvCxnSpPr>
-        <p:spPr>
-          <a:xfrm flipV="1">
-            <a:off x="5822239" y="4490566"/>
-            <a:ext cx="690165" cy="498341"/>
-          </a:xfrm>
-          <a:prstGeom prst="straightConnector1">
-            <a:avLst/>
-          </a:prstGeom>
-          <a:ln w="19050">
-            <a:prstDash val="sysDash"/>
-            <a:tailEnd type="triangle"/>
-          </a:ln>
-        </p:spPr>
-        <p:style>
-          <a:lnRef idx="1">
-            <a:schemeClr val="accent1"/>
-          </a:lnRef>
-          <a:fillRef idx="0">
-            <a:schemeClr val="accent1"/>
-          </a:fillRef>
-          <a:effectRef idx="0">
-            <a:schemeClr val="accent1"/>
-          </a:effectRef>
-          <a:fontRef idx="minor">
-            <a:schemeClr val="tx1"/>
-          </a:fontRef>
-        </p:style>
-      </p:cxnSp>
-      <p:cxnSp>
-        <p:nvCxnSpPr>
-          <p:cNvPr id="57" name="Straight Arrow Connector 56">
-            <a:extLst>
-              <a:ext uri="{FF2B5EF4-FFF2-40B4-BE49-F238E27FC236}">
-                <a16:creationId xmlns:a16="http://schemas.microsoft.com/office/drawing/2014/main" id="{83686D18-5E3C-57A0-75E1-6C0CC74536E2}"/>
-              </a:ext>
-            </a:extLst>
-          </p:cNvPr>
-          <p:cNvCxnSpPr>
-            <a:cxnSpLocks/>
-          </p:cNvCxnSpPr>
-          <p:nvPr/>
-        </p:nvCxnSpPr>
-        <p:spPr>
-          <a:xfrm flipH="1">
-            <a:off x="4859141" y="3588246"/>
-            <a:ext cx="470824" cy="561027"/>
-          </a:xfrm>
-          <a:prstGeom prst="straightConnector1">
-            <a:avLst/>
-          </a:prstGeom>
-          <a:ln w="19050">
-            <a:prstDash val="sysDash"/>
-            <a:tailEnd type="triangle"/>
-          </a:ln>
-        </p:spPr>
-        <p:style>
-          <a:lnRef idx="1">
-            <a:schemeClr val="accent1"/>
-          </a:lnRef>
-          <a:fillRef idx="0">
-            <a:schemeClr val="accent1"/>
-          </a:fillRef>
-          <a:effectRef idx="0">
-            <a:schemeClr val="accent1"/>
-          </a:effectRef>
-          <a:fontRef idx="minor">
-            <a:schemeClr val="tx1"/>
-          </a:fontRef>
-        </p:style>
-      </p:cxnSp>
-      <p:cxnSp>
-        <p:nvCxnSpPr>
-          <p:cNvPr id="60" name="Straight Arrow Connector 59">
-            <a:extLst>
-              <a:ext uri="{FF2B5EF4-FFF2-40B4-BE49-F238E27FC236}">
-                <a16:creationId xmlns:a16="http://schemas.microsoft.com/office/drawing/2014/main" id="{1F0423F2-4048-B9CC-2386-AFE6AE436AA1}"/>
-              </a:ext>
-            </a:extLst>
-          </p:cNvPr>
-          <p:cNvCxnSpPr>
-            <a:cxnSpLocks/>
-          </p:cNvCxnSpPr>
-          <p:nvPr/>
-        </p:nvCxnSpPr>
-        <p:spPr>
-          <a:xfrm flipH="1" flipV="1">
-            <a:off x="4859141" y="4528291"/>
-            <a:ext cx="470824" cy="594844"/>
-          </a:xfrm>
-          <a:prstGeom prst="straightConnector1">
-            <a:avLst/>
-          </a:prstGeom>
-          <a:ln w="19050">
-            <a:prstDash val="sysDash"/>
-            <a:tailEnd type="triangle"/>
-          </a:ln>
-        </p:spPr>
-        <p:style>
-          <a:lnRef idx="1">
-            <a:schemeClr val="accent1"/>
-          </a:lnRef>
-          <a:fillRef idx="0">
-            <a:schemeClr val="accent1"/>
-          </a:fillRef>
-          <a:effectRef idx="0">
-            <a:schemeClr val="accent1"/>
-          </a:effectRef>
-          <a:fontRef idx="minor">
-            <a:schemeClr val="tx1"/>
-          </a:fontRef>
-        </p:style>
-      </p:cxnSp>
-      <p:cxnSp>
-        <p:nvCxnSpPr>
-          <p:cNvPr id="65" name="Straight Arrow Connector 64">
-            <a:extLst>
-              <a:ext uri="{FF2B5EF4-FFF2-40B4-BE49-F238E27FC236}">
-                <a16:creationId xmlns:a16="http://schemas.microsoft.com/office/drawing/2014/main" id="{5DEDCD02-C96F-BCC1-98EC-87D833214342}"/>
-              </a:ext>
-            </a:extLst>
-          </p:cNvPr>
-          <p:cNvCxnSpPr>
-            <a:cxnSpLocks/>
-          </p:cNvCxnSpPr>
-          <p:nvPr/>
-        </p:nvCxnSpPr>
-        <p:spPr>
-          <a:xfrm flipH="1">
-            <a:off x="4928803" y="4436167"/>
-            <a:ext cx="1364259" cy="0"/>
           </a:xfrm>
           <a:prstGeom prst="straightConnector1">
             <a:avLst/>
@@ -6556,19 +6228,109 @@
           <p:cNvPr id="68" name="Straight Arrow Connector 67">
             <a:extLst>
               <a:ext uri="{FF2B5EF4-FFF2-40B4-BE49-F238E27FC236}">
-                <a16:creationId xmlns:a16="http://schemas.microsoft.com/office/drawing/2014/main" id="{CC3DD641-B3F0-E933-046D-55771630F531}"/>
+                <a16:creationId xmlns:a16="http://schemas.microsoft.com/office/drawing/2014/main" id="{68926775-101E-4F5D-D026-CA6FE51932B1}"/>
               </a:ext>
             </a:extLst>
           </p:cNvPr>
           <p:cNvCxnSpPr>
             <a:cxnSpLocks/>
+            <a:stCxn id="62" idx="3"/>
+            <a:endCxn id="63" idx="1"/>
           </p:cNvCxnSpPr>
           <p:nvPr/>
         </p:nvCxnSpPr>
         <p:spPr>
           <a:xfrm flipV="1">
-            <a:off x="5718722" y="3868759"/>
-            <a:ext cx="0" cy="935901"/>
+            <a:off x="4882586" y="4550546"/>
+            <a:ext cx="524413" cy="632569"/>
+          </a:xfrm>
+          <a:prstGeom prst="straightConnector1">
+            <a:avLst/>
+          </a:prstGeom>
+          <a:ln w="19050">
+            <a:prstDash val="sysDash"/>
+            <a:tailEnd type="triangle"/>
+          </a:ln>
+        </p:spPr>
+        <p:style>
+          <a:lnRef idx="1">
+            <a:schemeClr val="accent1"/>
+          </a:lnRef>
+          <a:fillRef idx="0">
+            <a:schemeClr val="accent1"/>
+          </a:fillRef>
+          <a:effectRef idx="0">
+            <a:schemeClr val="accent1"/>
+          </a:effectRef>
+          <a:fontRef idx="minor">
+            <a:schemeClr val="tx1"/>
+          </a:fontRef>
+        </p:style>
+      </p:cxnSp>
+      <p:cxnSp>
+        <p:nvCxnSpPr>
+          <p:cNvPr id="69" name="Straight Arrow Connector 68">
+            <a:extLst>
+              <a:ext uri="{FF2B5EF4-FFF2-40B4-BE49-F238E27FC236}">
+                <a16:creationId xmlns:a16="http://schemas.microsoft.com/office/drawing/2014/main" id="{4AC9BA77-F308-7AD6-97FC-475E8A512E8A}"/>
+              </a:ext>
+            </a:extLst>
+          </p:cNvPr>
+          <p:cNvCxnSpPr>
+            <a:cxnSpLocks/>
+            <a:stCxn id="63" idx="2"/>
+            <a:endCxn id="64" idx="0"/>
+          </p:cNvCxnSpPr>
+          <p:nvPr/>
+        </p:nvCxnSpPr>
+        <p:spPr>
+          <a:xfrm>
+            <a:off x="5626341" y="4734792"/>
+            <a:ext cx="1" cy="930378"/>
+          </a:xfrm>
+          <a:prstGeom prst="straightConnector1">
+            <a:avLst/>
+          </a:prstGeom>
+          <a:ln w="19050">
+            <a:prstDash val="sysDash"/>
+            <a:tailEnd type="triangle"/>
+          </a:ln>
+        </p:spPr>
+        <p:style>
+          <a:lnRef idx="1">
+            <a:schemeClr val="accent1"/>
+          </a:lnRef>
+          <a:fillRef idx="0">
+            <a:schemeClr val="accent1"/>
+          </a:fillRef>
+          <a:effectRef idx="0">
+            <a:schemeClr val="accent1"/>
+          </a:effectRef>
+          <a:fontRef idx="minor">
+            <a:schemeClr val="tx1"/>
+          </a:fontRef>
+        </p:style>
+      </p:cxnSp>
+      <p:cxnSp>
+        <p:nvCxnSpPr>
+          <p:cNvPr id="70" name="Straight Arrow Connector 69">
+            <a:extLst>
+              <a:ext uri="{FF2B5EF4-FFF2-40B4-BE49-F238E27FC236}">
+                <a16:creationId xmlns:a16="http://schemas.microsoft.com/office/drawing/2014/main" id="{62C510E6-A13B-A2E1-BA11-B73120B80C33}"/>
+              </a:ext>
+            </a:extLst>
+          </p:cNvPr>
+          <p:cNvCxnSpPr>
+            <a:cxnSpLocks/>
+            <a:stCxn id="63" idx="3"/>
+            <a:endCxn id="65" idx="0"/>
+          </p:cNvCxnSpPr>
+          <p:nvPr/>
+        </p:nvCxnSpPr>
+        <p:spPr>
+          <a:xfrm>
+            <a:off x="5845682" y="4550546"/>
+            <a:ext cx="690166" cy="432037"/>
           </a:xfrm>
           <a:prstGeom prst="straightConnector1">
             <a:avLst/>
@@ -6598,7 +6360,51 @@
           <p:cNvPr id="71" name="Straight Arrow Connector 70">
             <a:extLst>
               <a:ext uri="{FF2B5EF4-FFF2-40B4-BE49-F238E27FC236}">
-                <a16:creationId xmlns:a16="http://schemas.microsoft.com/office/drawing/2014/main" id="{69007A7E-74A5-A0BD-6E26-FED4FA6AD46E}"/>
+                <a16:creationId xmlns:a16="http://schemas.microsoft.com/office/drawing/2014/main" id="{6DECD70B-86BE-0869-7A87-D6847A03585F}"/>
+              </a:ext>
+            </a:extLst>
+          </p:cNvPr>
+          <p:cNvCxnSpPr>
+            <a:cxnSpLocks/>
+            <a:stCxn id="64" idx="3"/>
+            <a:endCxn id="65" idx="2"/>
+          </p:cNvCxnSpPr>
+          <p:nvPr/>
+        </p:nvCxnSpPr>
+        <p:spPr>
+          <a:xfrm flipV="1">
+            <a:off x="5845683" y="5351076"/>
+            <a:ext cx="690165" cy="498341"/>
+          </a:xfrm>
+          <a:prstGeom prst="straightConnector1">
+            <a:avLst/>
+          </a:prstGeom>
+          <a:ln w="19050">
+            <a:prstDash val="sysDash"/>
+            <a:tailEnd type="triangle"/>
+          </a:ln>
+        </p:spPr>
+        <p:style>
+          <a:lnRef idx="1">
+            <a:schemeClr val="accent1"/>
+          </a:lnRef>
+          <a:fillRef idx="0">
+            <a:schemeClr val="accent1"/>
+          </a:fillRef>
+          <a:effectRef idx="0">
+            <a:schemeClr val="accent1"/>
+          </a:effectRef>
+          <a:fontRef idx="minor">
+            <a:schemeClr val="tx1"/>
+          </a:fontRef>
+        </p:style>
+      </p:cxnSp>
+      <p:cxnSp>
+        <p:nvCxnSpPr>
+          <p:cNvPr id="72" name="Straight Arrow Connector 71">
+            <a:extLst>
+              <a:ext uri="{FF2B5EF4-FFF2-40B4-BE49-F238E27FC236}">
+                <a16:creationId xmlns:a16="http://schemas.microsoft.com/office/drawing/2014/main" id="{83686D18-5E3C-57A0-75E1-6C0CC74536E2}"/>
               </a:ext>
             </a:extLst>
           </p:cNvPr>
@@ -6608,9 +6414,93 @@
           <p:nvPr/>
         </p:nvCxnSpPr>
         <p:spPr>
+          <a:xfrm flipH="1">
+            <a:off x="4882585" y="4448756"/>
+            <a:ext cx="470824" cy="561027"/>
+          </a:xfrm>
+          <a:prstGeom prst="straightConnector1">
+            <a:avLst/>
+          </a:prstGeom>
+          <a:ln w="19050">
+            <a:prstDash val="sysDash"/>
+            <a:tailEnd type="triangle"/>
+          </a:ln>
+        </p:spPr>
+        <p:style>
+          <a:lnRef idx="1">
+            <a:schemeClr val="accent1"/>
+          </a:lnRef>
+          <a:fillRef idx="0">
+            <a:schemeClr val="accent1"/>
+          </a:fillRef>
+          <a:effectRef idx="0">
+            <a:schemeClr val="accent1"/>
+          </a:effectRef>
+          <a:fontRef idx="minor">
+            <a:schemeClr val="tx1"/>
+          </a:fontRef>
+        </p:style>
+      </p:cxnSp>
+      <p:cxnSp>
+        <p:nvCxnSpPr>
+          <p:cNvPr id="73" name="Straight Arrow Connector 72">
+            <a:extLst>
+              <a:ext uri="{FF2B5EF4-FFF2-40B4-BE49-F238E27FC236}">
+                <a16:creationId xmlns:a16="http://schemas.microsoft.com/office/drawing/2014/main" id="{1F0423F2-4048-B9CC-2386-AFE6AE436AA1}"/>
+              </a:ext>
+            </a:extLst>
+          </p:cNvPr>
+          <p:cNvCxnSpPr>
+            <a:cxnSpLocks/>
+          </p:cNvCxnSpPr>
+          <p:nvPr/>
+        </p:nvCxnSpPr>
+        <p:spPr>
           <a:xfrm flipH="1" flipV="1">
-            <a:off x="5840224" y="3580895"/>
-            <a:ext cx="672179" cy="425425"/>
+            <a:off x="4882585" y="5388801"/>
+            <a:ext cx="470824" cy="594844"/>
+          </a:xfrm>
+          <a:prstGeom prst="straightConnector1">
+            <a:avLst/>
+          </a:prstGeom>
+          <a:ln w="19050">
+            <a:prstDash val="sysDash"/>
+            <a:tailEnd type="triangle"/>
+          </a:ln>
+        </p:spPr>
+        <p:style>
+          <a:lnRef idx="1">
+            <a:schemeClr val="accent1"/>
+          </a:lnRef>
+          <a:fillRef idx="0">
+            <a:schemeClr val="accent1"/>
+          </a:fillRef>
+          <a:effectRef idx="0">
+            <a:schemeClr val="accent1"/>
+          </a:effectRef>
+          <a:fontRef idx="minor">
+            <a:schemeClr val="tx1"/>
+          </a:fontRef>
+        </p:style>
+      </p:cxnSp>
+      <p:cxnSp>
+        <p:nvCxnSpPr>
+          <p:cNvPr id="74" name="Straight Arrow Connector 73">
+            <a:extLst>
+              <a:ext uri="{FF2B5EF4-FFF2-40B4-BE49-F238E27FC236}">
+                <a16:creationId xmlns:a16="http://schemas.microsoft.com/office/drawing/2014/main" id="{5DEDCD02-C96F-BCC1-98EC-87D833214342}"/>
+              </a:ext>
+            </a:extLst>
+          </p:cNvPr>
+          <p:cNvCxnSpPr>
+            <a:cxnSpLocks/>
+          </p:cNvCxnSpPr>
+          <p:nvPr/>
+        </p:nvCxnSpPr>
+        <p:spPr>
+          <a:xfrm flipH="1">
+            <a:off x="4952247" y="5296677"/>
+            <a:ext cx="1364259" cy="0"/>
           </a:xfrm>
           <a:prstGeom prst="straightConnector1">
             <a:avLst/>
@@ -6640,7 +6530,7 @@
           <p:cNvPr id="75" name="Straight Arrow Connector 74">
             <a:extLst>
               <a:ext uri="{FF2B5EF4-FFF2-40B4-BE49-F238E27FC236}">
-                <a16:creationId xmlns:a16="http://schemas.microsoft.com/office/drawing/2014/main" id="{504D38E3-0655-1B41-7851-425F1CC78194}"/>
+                <a16:creationId xmlns:a16="http://schemas.microsoft.com/office/drawing/2014/main" id="{CC3DD641-B3F0-E933-046D-55771630F531}"/>
               </a:ext>
             </a:extLst>
           </p:cNvPr>
@@ -6650,8 +6540,92 @@
           <p:nvPr/>
         </p:nvCxnSpPr>
         <p:spPr>
+          <a:xfrm flipV="1">
+            <a:off x="5742166" y="4729269"/>
+            <a:ext cx="0" cy="935901"/>
+          </a:xfrm>
+          <a:prstGeom prst="straightConnector1">
+            <a:avLst/>
+          </a:prstGeom>
+          <a:ln w="19050">
+            <a:prstDash val="sysDash"/>
+            <a:tailEnd type="triangle"/>
+          </a:ln>
+        </p:spPr>
+        <p:style>
+          <a:lnRef idx="1">
+            <a:schemeClr val="accent1"/>
+          </a:lnRef>
+          <a:fillRef idx="0">
+            <a:schemeClr val="accent1"/>
+          </a:fillRef>
+          <a:effectRef idx="0">
+            <a:schemeClr val="accent1"/>
+          </a:effectRef>
+          <a:fontRef idx="minor">
+            <a:schemeClr val="tx1"/>
+          </a:fontRef>
+        </p:style>
+      </p:cxnSp>
+      <p:cxnSp>
+        <p:nvCxnSpPr>
+          <p:cNvPr id="76" name="Straight Arrow Connector 75">
+            <a:extLst>
+              <a:ext uri="{FF2B5EF4-FFF2-40B4-BE49-F238E27FC236}">
+                <a16:creationId xmlns:a16="http://schemas.microsoft.com/office/drawing/2014/main" id="{69007A7E-74A5-A0BD-6E26-FED4FA6AD46E}"/>
+              </a:ext>
+            </a:extLst>
+          </p:cNvPr>
+          <p:cNvCxnSpPr>
+            <a:cxnSpLocks/>
+          </p:cNvCxnSpPr>
+          <p:nvPr/>
+        </p:nvCxnSpPr>
+        <p:spPr>
+          <a:xfrm flipH="1" flipV="1">
+            <a:off x="5863668" y="4441405"/>
+            <a:ext cx="672179" cy="425425"/>
+          </a:xfrm>
+          <a:prstGeom prst="straightConnector1">
+            <a:avLst/>
+          </a:prstGeom>
+          <a:ln w="19050">
+            <a:prstDash val="sysDash"/>
+            <a:tailEnd type="triangle"/>
+          </a:ln>
+        </p:spPr>
+        <p:style>
+          <a:lnRef idx="1">
+            <a:schemeClr val="accent1"/>
+          </a:lnRef>
+          <a:fillRef idx="0">
+            <a:schemeClr val="accent1"/>
+          </a:fillRef>
+          <a:effectRef idx="0">
+            <a:schemeClr val="accent1"/>
+          </a:effectRef>
+          <a:fontRef idx="minor">
+            <a:schemeClr val="tx1"/>
+          </a:fontRef>
+        </p:style>
+      </p:cxnSp>
+      <p:cxnSp>
+        <p:nvCxnSpPr>
+          <p:cNvPr id="77" name="Straight Arrow Connector 76">
+            <a:extLst>
+              <a:ext uri="{FF2B5EF4-FFF2-40B4-BE49-F238E27FC236}">
+                <a16:creationId xmlns:a16="http://schemas.microsoft.com/office/drawing/2014/main" id="{504D38E3-0655-1B41-7851-425F1CC78194}"/>
+              </a:ext>
+            </a:extLst>
+          </p:cNvPr>
+          <p:cNvCxnSpPr>
+            <a:cxnSpLocks/>
+          </p:cNvCxnSpPr>
+          <p:nvPr/>
+        </p:nvCxnSpPr>
+        <p:spPr>
           <a:xfrm flipH="1">
-            <a:off x="5895087" y="4577765"/>
+            <a:off x="5918531" y="5438275"/>
             <a:ext cx="636573" cy="481332"/>
           </a:xfrm>
           <a:prstGeom prst="straightConnector1">
@@ -6679,7 +6653,7 @@
       </p:cxnSp>
       <p:pic>
         <p:nvPicPr>
-          <p:cNvPr id="77" name="Picture 2" descr="Document, file, record, recording icon - Download on Iconfinder">
+          <p:cNvPr id="78" name="Picture 2" descr="Document, file, record, recording icon - Download on Iconfinder">
             <a:extLst>
               <a:ext uri="{FF2B5EF4-FFF2-40B4-BE49-F238E27FC236}">
                 <a16:creationId xmlns:a16="http://schemas.microsoft.com/office/drawing/2014/main" id="{90944191-B900-A1E0-5122-4DB602596542}"/>
@@ -6692,7 +6666,7 @@
           <p:nvPr/>
         </p:nvPicPr>
         <p:blipFill>
-          <a:blip r:embed="rId3">
+          <a:blip r:embed="rId4">
             <a:extLst>
               <a:ext uri="{28A0092B-C50C-407E-A947-70E740481C1C}">
                 <a14:useLocalDpi xmlns:a14="http://schemas.microsoft.com/office/drawing/2010/main" val="0"/>
@@ -6706,7 +6680,7 @@
         </p:blipFill>
         <p:spPr bwMode="auto">
           <a:xfrm>
-            <a:off x="7032710" y="3628990"/>
+            <a:off x="7056154" y="4489500"/>
             <a:ext cx="438683" cy="438683"/>
           </a:xfrm>
           <a:prstGeom prst="rect">
@@ -6734,14 +6708,14 @@
             </a:extLst>
           </p:cNvPr>
           <p:cNvCxnSpPr>
-            <a:stCxn id="34" idx="3"/>
-            <a:endCxn id="77" idx="1"/>
+            <a:stCxn id="63" idx="3"/>
+            <a:endCxn id="78" idx="1"/>
           </p:cNvCxnSpPr>
           <p:nvPr/>
         </p:nvCxnSpPr>
         <p:spPr>
           <a:xfrm>
-            <a:off x="5822238" y="3690036"/>
+            <a:off x="5845682" y="4550546"/>
             <a:ext cx="1210472" cy="158296"/>
           </a:xfrm>
           <a:prstGeom prst="bentConnector3">
@@ -6777,14 +6751,14 @@
           </p:cNvPr>
           <p:cNvCxnSpPr>
             <a:cxnSpLocks/>
-            <a:stCxn id="36" idx="3"/>
-            <a:endCxn id="77" idx="2"/>
+            <a:stCxn id="65" idx="3"/>
+            <a:endCxn id="78" idx="2"/>
           </p:cNvCxnSpPr>
           <p:nvPr/>
         </p:nvCxnSpPr>
         <p:spPr>
           <a:xfrm flipV="1">
-            <a:off x="6731745" y="4067673"/>
+            <a:off x="6755189" y="4928183"/>
             <a:ext cx="520307" cy="238647"/>
           </a:xfrm>
           <a:prstGeom prst="bentConnector2">
@@ -6820,14 +6794,14 @@
           </p:cNvPr>
           <p:cNvCxnSpPr>
             <a:cxnSpLocks/>
-            <a:stCxn id="35" idx="3"/>
-            <a:endCxn id="77" idx="3"/>
+            <a:stCxn id="64" idx="3"/>
+            <a:endCxn id="78" idx="3"/>
           </p:cNvCxnSpPr>
           <p:nvPr/>
         </p:nvCxnSpPr>
         <p:spPr>
           <a:xfrm flipV="1">
-            <a:off x="5822239" y="3848332"/>
+            <a:off x="5845683" y="4708842"/>
             <a:ext cx="1649154" cy="1140575"/>
           </a:xfrm>
           <a:prstGeom prst="bentConnector3">
@@ -6865,14 +6839,14 @@
           </p:cNvPr>
           <p:cNvCxnSpPr>
             <a:cxnSpLocks/>
-            <a:stCxn id="33" idx="0"/>
-            <a:endCxn id="77" idx="0"/>
+            <a:stCxn id="62" idx="0"/>
+            <a:endCxn id="78" idx="0"/>
           </p:cNvCxnSpPr>
           <p:nvPr/>
         </p:nvCxnSpPr>
         <p:spPr>
           <a:xfrm rot="5400000" flipH="1" flipV="1">
-            <a:off x="5691242" y="2577549"/>
+            <a:off x="5714686" y="3438059"/>
             <a:ext cx="509368" cy="2612251"/>
           </a:xfrm>
           <a:prstGeom prst="bentConnector3">
@@ -6914,7 +6888,7 @@
           <p:nvPr/>
         </p:nvPicPr>
         <p:blipFill>
-          <a:blip r:embed="rId2">
+          <a:blip r:embed="rId3">
             <a:extLst>
               <a:ext uri="{28A0092B-C50C-407E-A947-70E740481C1C}">
                 <a14:useLocalDpi xmlns:a14="http://schemas.microsoft.com/office/drawing/2010/main" val="0"/>
@@ -6927,7 +6901,7 @@
         </p:blipFill>
         <p:spPr>
           <a:xfrm>
-            <a:off x="8428122" y="3954111"/>
+            <a:off x="8451566" y="4814621"/>
             <a:ext cx="438683" cy="368493"/>
           </a:xfrm>
           <a:prstGeom prst="rect">
@@ -6955,7 +6929,7 @@
           <p:nvPr/>
         </p:nvPicPr>
         <p:blipFill>
-          <a:blip r:embed="rId2">
+          <a:blip r:embed="rId3">
             <a:extLst>
               <a:ext uri="{28A0092B-C50C-407E-A947-70E740481C1C}">
                 <a14:useLocalDpi xmlns:a14="http://schemas.microsoft.com/office/drawing/2010/main" val="0"/>
@@ -6968,7 +6942,7 @@
         </p:blipFill>
         <p:spPr>
           <a:xfrm>
-            <a:off x="9988623" y="3932585"/>
+            <a:off x="10012067" y="4793095"/>
             <a:ext cx="438683" cy="368493"/>
           </a:xfrm>
           <a:prstGeom prst="rect">
@@ -6996,7 +6970,7 @@
           <p:nvPr/>
         </p:nvPicPr>
         <p:blipFill>
-          <a:blip r:embed="rId3">
+          <a:blip r:embed="rId4">
             <a:extLst>
               <a:ext uri="{28A0092B-C50C-407E-A947-70E740481C1C}">
                 <a14:useLocalDpi xmlns:a14="http://schemas.microsoft.com/office/drawing/2010/main" val="0"/>
@@ -7010,7 +6984,7 @@
         </p:blipFill>
         <p:spPr bwMode="auto">
           <a:xfrm>
-            <a:off x="9035457" y="4544826"/>
+            <a:off x="9058901" y="5405336"/>
             <a:ext cx="438683" cy="438683"/>
           </a:xfrm>
           <a:prstGeom prst="rect">
@@ -7043,7 +7017,7 @@
           <p:nvPr/>
         </p:nvPicPr>
         <p:blipFill>
-          <a:blip r:embed="rId2">
+          <a:blip r:embed="rId3">
             <a:extLst>
               <a:ext uri="{28A0092B-C50C-407E-A947-70E740481C1C}">
                 <a14:useLocalDpi xmlns:a14="http://schemas.microsoft.com/office/drawing/2010/main" val="0"/>
@@ -7056,7 +7030,7 @@
         </p:blipFill>
         <p:spPr>
           <a:xfrm>
-            <a:off x="9035458" y="3244753"/>
+            <a:off x="9058902" y="4105263"/>
             <a:ext cx="438683" cy="368493"/>
           </a:xfrm>
           <a:prstGeom prst="rect">
@@ -7084,7 +7058,7 @@
           <p:nvPr/>
         </p:nvPicPr>
         <p:blipFill>
-          <a:blip r:embed="rId2">
+          <a:blip r:embed="rId3">
             <a:extLst>
               <a:ext uri="{28A0092B-C50C-407E-A947-70E740481C1C}">
                 <a14:useLocalDpi xmlns:a14="http://schemas.microsoft.com/office/drawing/2010/main" val="0"/>
@@ -7097,7 +7071,7 @@
         </p:blipFill>
         <p:spPr>
           <a:xfrm>
-            <a:off x="10965780" y="3937452"/>
+            <a:off x="10989224" y="4797962"/>
             <a:ext cx="438683" cy="368493"/>
           </a:xfrm>
           <a:prstGeom prst="rect">
@@ -7125,7 +7099,7 @@
           <p:nvPr/>
         </p:nvPicPr>
         <p:blipFill>
-          <a:blip r:embed="rId3">
+          <a:blip r:embed="rId4">
             <a:extLst>
               <a:ext uri="{28A0092B-C50C-407E-A947-70E740481C1C}">
                 <a14:useLocalDpi xmlns:a14="http://schemas.microsoft.com/office/drawing/2010/main" val="0"/>
@@ -7139,7 +7113,7 @@
         </p:blipFill>
         <p:spPr bwMode="auto">
           <a:xfrm>
-            <a:off x="9948118" y="4506852"/>
+            <a:off x="9971562" y="5367362"/>
             <a:ext cx="438684" cy="438684"/>
           </a:xfrm>
           <a:prstGeom prst="rect">
@@ -7174,7 +7148,7 @@
         </p:nvCxnSpPr>
         <p:spPr>
           <a:xfrm flipV="1">
-            <a:off x="8647464" y="3475220"/>
+            <a:off x="8670908" y="4335730"/>
             <a:ext cx="372290" cy="478891"/>
           </a:xfrm>
           <a:prstGeom prst="straightConnector1">
@@ -7216,7 +7190,7 @@
         </p:nvCxnSpPr>
         <p:spPr>
           <a:xfrm flipH="1">
-            <a:off x="8830720" y="3624009"/>
+            <a:off x="8854164" y="4484519"/>
             <a:ext cx="245887" cy="308576"/>
           </a:xfrm>
           <a:prstGeom prst="straightConnector1">
@@ -7260,7 +7234,7 @@
         </p:nvCxnSpPr>
         <p:spPr>
           <a:xfrm flipV="1">
-            <a:off x="8866805" y="4116832"/>
+            <a:off x="8890249" y="4977342"/>
             <a:ext cx="1121818" cy="21526"/>
           </a:xfrm>
           <a:prstGeom prst="straightConnector1">
@@ -7303,7 +7277,7 @@
         </p:nvCxnSpPr>
         <p:spPr>
           <a:xfrm>
-            <a:off x="8738944" y="4350766"/>
+            <a:off x="8762388" y="5211276"/>
             <a:ext cx="515855" cy="194060"/>
           </a:xfrm>
           <a:prstGeom prst="straightConnector1">
@@ -7349,7 +7323,7 @@
         </p:nvCxnSpPr>
         <p:spPr>
           <a:xfrm flipH="1">
-            <a:off x="9254799" y="3613246"/>
+            <a:off x="9278243" y="4473756"/>
             <a:ext cx="1" cy="931580"/>
           </a:xfrm>
           <a:prstGeom prst="straightConnector1">
@@ -7395,7 +7369,7 @@
         </p:nvCxnSpPr>
         <p:spPr>
           <a:xfrm>
-            <a:off x="9474141" y="3429000"/>
+            <a:off x="9497585" y="4289510"/>
             <a:ext cx="733824" cy="503585"/>
           </a:xfrm>
           <a:prstGeom prst="straightConnector1">
@@ -7439,7 +7413,7 @@
         </p:nvCxnSpPr>
         <p:spPr>
           <a:xfrm flipH="1">
-            <a:off x="10167460" y="4301078"/>
+            <a:off x="10190904" y="5161588"/>
             <a:ext cx="0" cy="205774"/>
           </a:xfrm>
           <a:prstGeom prst="straightConnector1">
@@ -7482,7 +7456,7 @@
           <p:nvPr/>
         </p:nvPicPr>
         <p:blipFill>
-          <a:blip r:embed="rId3">
+          <a:blip r:embed="rId4">
             <a:extLst>
               <a:ext uri="{28A0092B-C50C-407E-A947-70E740481C1C}">
                 <a14:useLocalDpi xmlns:a14="http://schemas.microsoft.com/office/drawing/2010/main" val="0"/>
@@ -7496,7 +7470,7 @@
         </p:blipFill>
         <p:spPr bwMode="auto">
           <a:xfrm>
-            <a:off x="10965780" y="4502709"/>
+            <a:off x="10989224" y="5363219"/>
             <a:ext cx="438684" cy="438684"/>
           </a:xfrm>
           <a:prstGeom prst="rect">
@@ -7530,7 +7504,7 @@
         </p:nvCxnSpPr>
         <p:spPr>
           <a:xfrm flipH="1">
-            <a:off x="11185121" y="4322604"/>
+            <a:off x="11208565" y="5183114"/>
             <a:ext cx="0" cy="205774"/>
           </a:xfrm>
           <a:prstGeom prst="straightConnector1">
@@ -7575,7 +7549,7 @@
         </p:nvCxnSpPr>
         <p:spPr>
           <a:xfrm>
-            <a:off x="10466844" y="4106155"/>
+            <a:off x="10490288" y="4966665"/>
             <a:ext cx="498936" cy="15544"/>
           </a:xfrm>
           <a:prstGeom prst="straightConnector1">
@@ -7619,7 +7593,7 @@
         </p:nvCxnSpPr>
         <p:spPr>
           <a:xfrm rot="16200000" flipV="1">
-            <a:off x="10075406" y="2827735"/>
+            <a:off x="10098850" y="3688245"/>
             <a:ext cx="508452" cy="1710981"/>
           </a:xfrm>
           <a:prstGeom prst="bentConnector2">
@@ -7664,7 +7638,7 @@
         </p:nvCxnSpPr>
         <p:spPr>
           <a:xfrm>
-            <a:off x="771978" y="5134744"/>
+            <a:off x="795422" y="5995254"/>
             <a:ext cx="453021" cy="0"/>
           </a:xfrm>
           <a:prstGeom prst="straightConnector1">
@@ -7704,7 +7678,7 @@
         </p:nvSpPr>
         <p:spPr>
           <a:xfrm>
-            <a:off x="1252943" y="4996244"/>
+            <a:off x="1276387" y="5856754"/>
             <a:ext cx="1218023" cy="276999"/>
           </a:xfrm>
           <a:prstGeom prst="rect">
@@ -7754,7 +7728,7 @@
         </p:nvCxnSpPr>
         <p:spPr>
           <a:xfrm>
-            <a:off x="2649660" y="5134743"/>
+            <a:off x="2673104" y="5995253"/>
             <a:ext cx="362181" cy="0"/>
           </a:xfrm>
           <a:prstGeom prst="straightConnector1">
@@ -7796,7 +7770,7 @@
         </p:nvSpPr>
         <p:spPr>
           <a:xfrm>
-            <a:off x="3012954" y="4996243"/>
+            <a:off x="3036398" y="5856753"/>
             <a:ext cx="1470286" cy="276999"/>
           </a:xfrm>
           <a:prstGeom prst="rect">
@@ -7831,7 +7805,7 @@
         </p:nvSpPr>
         <p:spPr>
           <a:xfrm>
-            <a:off x="624969" y="2889017"/>
+            <a:off x="648413" y="3749527"/>
             <a:ext cx="2853524" cy="276999"/>
           </a:xfrm>
           <a:prstGeom prst="rect">
@@ -7866,7 +7840,7 @@
         </p:nvSpPr>
         <p:spPr>
           <a:xfrm>
-            <a:off x="4599426" y="2876583"/>
+            <a:off x="4622870" y="3737093"/>
             <a:ext cx="2238591" cy="276999"/>
           </a:xfrm>
           <a:prstGeom prst="rect">
@@ -7901,7 +7875,7 @@
         </p:nvSpPr>
         <p:spPr>
           <a:xfrm>
-            <a:off x="8652328" y="2881594"/>
+            <a:off x="8675772" y="3742104"/>
             <a:ext cx="2238591" cy="276999"/>
           </a:xfrm>
           <a:prstGeom prst="rect">
@@ -7925,7 +7899,7 @@
     </p:spTree>
     <p:extLst>
       <p:ext uri="{BB962C8B-B14F-4D97-AF65-F5344CB8AC3E}">
-        <p14:creationId xmlns:p14="http://schemas.microsoft.com/office/powerpoint/2010/main" val="3098780687"/>
+        <p14:creationId xmlns:p14="http://schemas.microsoft.com/office/powerpoint/2010/main" val="1817311260"/>
       </p:ext>
     </p:extLst>
   </p:cSld>
@@ -7935,7 +7909,7 @@
 </p:sld>
 </file>
 
-<file path=ppt/slides/slide3.xml><?xml version="1.0" encoding="utf-8"?>
+<file path=ppt/slides/slide2.xml><?xml version="1.0" encoding="utf-8"?>
 <p:sld xmlns:a="http://schemas.openxmlformats.org/drawingml/2006/main" xmlns:r="http://schemas.openxmlformats.org/officeDocument/2006/relationships" xmlns:p="http://schemas.openxmlformats.org/presentationml/2006/main">
   <p:cSld>
     <p:spTree>

</xml_diff>